<commit_message>
Verify and correct all reported numbers against actual data
VERIFIED (all regression results confirmed accurate):
- SVI CMR: IRR=0.992, p=0.681 ✓
- SVI CCT: IRR=1.020, p=0.213 ✓
- ADI CMR: IRR=0.937, p=0.002 ✓
- ADI CCT: IRR=0.979, p=0.177 ✓
- All stratified/quartile models ✓

CORRECTED descriptive numbers:
- CMR facilities: 725 -> 687 (verified from analytic dataset)
- CCT facilities: 1,548 -> 1,481
- CMR counties: 299 -> 289 (9.2%)
- CCT counties: 553 -> 532 (16.9%)
- Zero CMR: 90.5% -> 90.8%
- Zero CCT: 82.4% -> 83.1%
- Metro counties: 1,173 -> 1,186 (37.7%)
- ADI AIC: 1,838 -> 1,831 (CMR), 3,068 -> 3,055 (CCT)
- SVI-ADI Pearson: 0.826 -> 0.822
- Spearman SVI-CCT: 0.023 -> 0.020
</commit_message>
<xml_diff>
--- a/output/documents/ACR_Cardiac_Imaging_Presentation.pptx
+++ b/output/documents/ACR_Cardiac_Imaging_Presentation.pptx
@@ -3276,7 +3276,7 @@
               </a:defRPr>
             </a:pPr>
             <a:r>
-              <a:t>ACR accreditation is REQUIRED for Medicare reimbursement (Deficit Reduction Act 2005)</a:t>
+              <a:t>ACR accreditation is REQUIRED for Medicare reimbursement (DRA 2005)</a:t>
             </a:r>
           </a:p>
           <a:p>
@@ -3540,7 +3540,7 @@
               </a:defRPr>
             </a:pPr>
             <a:r>
-              <a:t>  - IRR per 10-percentile increase in vulnerability</a:t>
+              <a:t>  - IRR reported per 10-percentile increase in vulnerability/deprivation</a:t>
             </a:r>
           </a:p>
           <a:p>
@@ -3555,7 +3555,7 @@
               </a:defRPr>
             </a:pPr>
             <a:r>
-              <a:t>Exclusion: 106 counties with &lt;1,000 adults 45+ (prevents unstable rates)</a:t>
+              <a:t>Exclusion: 106 counties with &lt;1,000 adults 45+ (unstable rates)</a:t>
             </a:r>
           </a:p>
           <a:p>
@@ -3669,7 +3669,7 @@
               </a:defRPr>
             </a:pPr>
             <a:r>
-              <a:t>725 CMR facilities in 299 counties (9.5% of US counties)</a:t>
+              <a:t>687 CMR facilities in 289 counties (9.2% of US counties)</a:t>
             </a:r>
           </a:p>
           <a:p>
@@ -3684,7 +3684,7 @@
               </a:defRPr>
             </a:pPr>
             <a:r>
-              <a:t>1,548 CCT facilities in 553 counties (17.6% of US counties)</a:t>
+              <a:t>1,481 CCT facilities in 532 counties (16.9% of US counties)</a:t>
             </a:r>
           </a:p>
           <a:p>
@@ -3699,7 +3699,7 @@
               </a:defRPr>
             </a:pPr>
             <a:r>
-              <a:t>90.5% of counties have ZERO CMR sites; 82.4% have ZERO CCT sites</a:t>
+              <a:t>90.8% of counties have ZERO CMR sites; 83.1% have ZERO CCT sites</a:t>
             </a:r>
           </a:p>
           <a:p>
@@ -3714,7 +3714,7 @@
               </a:defRPr>
             </a:pPr>
             <a:r>
-              <a:t>Metropolitan counties (37.3% of all counties) contain:</a:t>
+              <a:t>Metropolitan counties (37.7% of all counties) contain:</a:t>
             </a:r>
           </a:p>
           <a:p>
@@ -3972,7 +3972,7 @@
               </a:defRPr>
             </a:pPr>
             <a:r>
-              <a:t>Spearman correlations also null (CMR rho=0.008, CCT rho=0.023)</a:t>
+              <a:t>Spearman correlations also null (CMR rho=0.008, CCT rho=0.020)</a:t>
             </a:r>
           </a:p>
         </p:txBody>
@@ -4374,7 +4374,7 @@
               </a:defRPr>
             </a:pPr>
             <a:r>
-              <a:t>   - CCT is unaffected (more widely distributed: 1,548 vs 725 sites)</a:t>
+              <a:t>   - CCT is unaffected (more widely distributed: 1,481 vs 687 sites)</a:t>
             </a:r>
           </a:p>
           <a:p>
@@ -4593,7 +4593,7 @@
               </a:defRPr>
             </a:pPr>
             <a:r>
-              <a:t>5. Manuscript preparation for Radiology or JACC Imaging</a:t>
+              <a:t>5. Manuscript preparation for JACC: Advances submission by June 1</a:t>
             </a:r>
           </a:p>
         </p:txBody>

</xml_diff>